<commit_message>
docs: sync all evidence to binary-store build — re-measured metrics
Unit I §4.3 rewritten as the binary-file persistence decision (CDB1
header, MessagePack+deflate payload, CRC32-on-read, one-time JSON
migration). All counts re-measured, not edited: 123 tests (71 unit +
52 integration), 1,585 LOC / 321 fns, avg CC 2.15, coverage 82.38/66.61/
76.25/88.84 (store 92.12, routes 85.51). COCOMO recomputed on 1.585
KLOC (3.89 PM, 3.93-month schedule, 1.8x capacity ratio). Defect log
grows AUTH-001 (/auth/me principal-shape drift on refresh) and E2E-004
(.stat commit race) — both found and closed this round, with the
regression assertions named. Deck generators + exported PPTX rebuilt
from the corrected sources.
</commit_message>
<xml_diff>
--- a/presentation/unit-1/CLMS-Unit-1-SE-Fundamentals-and-Design.pptx
+++ b/presentation/unit-1/CLMS-Unit-1-SE-Fundamentals-and-Design.pptx
@@ -9334,7 +9334,7 @@
                 <a:latin typeface="Menlo"/>
                 <a:ea typeface="Menlo"/>
               </a:rPr>
-              <a:t>JsonStore</a:t>
+              <a:t>BinaryStore</a:t>
             </a:r>
           </a:p>
         </p:txBody>
@@ -9374,7 +9374,7 @@
                 <a:latin typeface="Helvetica"/>
                 <a:ea typeface="Helvetica"/>
               </a:rPr>
-              <a:t>L5 · JSONSTORE</a:t>
+              <a:t>L5 · BINARYSTORE</a:t>
             </a:r>
           </a:p>
         </p:txBody>
@@ -9414,7 +9414,7 @@
                 <a:latin typeface="Helvetica"/>
                 <a:ea typeface="Helvetica"/>
               </a:rPr>
-              <a:t>tmp file + atomic rename · crash-safe</a:t>
+              <a:t>.cdb container · tmp+rename · CRC32-checked</a:t>
             </a:r>
           </a:p>
         </p:txBody>
@@ -9499,7 +9499,7 @@
                 <a:latin typeface="Helvetica"/>
                 <a:ea typeface="Helvetica"/>
               </a:rPr>
-              <a:t>JSON files instead of Postgres — an explicit requirement, answered with atomic persistence</a:t>
+              <a:t>Binary .cdb files in local storage instead of Postgres — atomic, CRC32-guarded persistence</a:t>
             </a:r>
           </a:p>
         </p:txBody>
@@ -9539,7 +9539,7 @@
                 <a:latin typeface="Menlo"/>
                 <a:ea typeface="Menlo"/>
               </a:rPr>
-              <a:t>System scale: 29 source files · 1,498 LOC · 314 functions · ~45 REST endpoints</a:t>
+              <a:t>System scale: 29 source files · 1,585 LOC · 321 functions · ~45 REST endpoints</a:t>
             </a:r>
           </a:p>
         </p:txBody>
@@ -14693,7 +14693,7 @@
                 <a:latin typeface="Helvetica"/>
                 <a:ea typeface="Helvetica"/>
               </a:rPr>
-              <a:t>Layered backend · JsonStore · barcodes · data · principles</a:t>
+              <a:t>Layered backend · binary store · barcodes · data · principles</a:t>
             </a:r>
           </a:p>
         </p:txBody>
@@ -18918,7 +18918,7 @@
                           <a:latin typeface="Helvetica"/>
                           <a:ea typeface="Helvetica"/>
                         </a:rPr>
-                        <a:t>Five strict layers · avg CC 2.13</a:t>
+                        <a:t>Five strict layers · avg CC 2.15</a:t>
                       </a:r>
                     </a:p>
                   </a:txBody>
@@ -23818,7 +23818,7 @@
                 <a:latin typeface="Helvetica"/>
                 <a:ea typeface="Helvetica"/>
               </a:rPr>
-              <a:t>Copy owns the state machine of the next slide. Loan and Reservation reference Member, Title and Copy by id — JsonStore persists one collection per entity, and joins happen in the domain layer.</a:t>
+              <a:t>Copy owns the state machine of the next slide. Loan and Reservation reference Member, Title and Copy by id — BinaryStore persists each collection as one opaque .cdb binary file, and joins happen in the domain layer.</a:t>
             </a:r>
           </a:p>
         </p:txBody>

</xml_diff>

<commit_message>
feat: wipe library data to clean slate, rebrand CLMS -> KCT Library
All library data (books, copies, members, loans, reservations, penalties,
notifications, audit) cleared; staff accounts kept and NidhishGuhan +
KawaskarJ (KCT@2006, ADMIN) recreated. UI brand, docs, all three decks and
the console banner now read KCT Library; the legacy Jira project is renamed
'KCT Library — legacy backlog' and the live board is NG space NS/KCT Library
with 7 closed sprints. Terminology and workflow unchanged; 123 tests green.
</commit_message>
<xml_diff>
--- a/presentation/unit-1/CLMS-Unit-1-SE-Fundamentals-and-Design.pptx
+++ b/presentation/unit-1/CLMS-Unit-1-SE-Fundamentals-and-Design.pptx
@@ -3511,7 +3511,7 @@
                 <a:latin typeface="Helvetica"/>
                 <a:ea typeface="Helvetica"/>
               </a:rPr>
-              <a:t>How CLMS was framed, specified and designed before the first sprint opened.</a:t>
+              <a:t>How KCT Library was framed, specified and designed before the first sprint opened.</a:t>
             </a:r>
           </a:p>
         </p:txBody>
@@ -6227,7 +6227,7 @@
                 <a:latin typeface="Helvetica"/>
                 <a:ea typeface="Helvetica"/>
               </a:rPr>
-              <a:t>CLMS · 24CSI015 · Software Engineering with Agile Practices</a:t>
+              <a:t>KCT Library · 24CSI015 · Software Engineering with Agile Practices</a:t>
             </a:r>
           </a:p>
         </p:txBody>
@@ -7918,7 +7918,7 @@
                 <a:latin typeface="Helvetica"/>
                 <a:ea typeface="Helvetica"/>
               </a:rPr>
-              <a:t>CLMS · 24CSI015 · Software Engineering with Agile Practices</a:t>
+              <a:t>KCT Library · 24CSI015 · Software Engineering with Agile Practices</a:t>
             </a:r>
           </a:p>
         </p:txBody>
@@ -9624,7 +9624,7 @@
                 <a:latin typeface="Helvetica"/>
                 <a:ea typeface="Helvetica"/>
               </a:rPr>
-              <a:t>CLMS · 24CSI015 · Software Engineering with Agile Practices</a:t>
+              <a:t>KCT Library · 24CSI015 · Software Engineering with Agile Practices</a:t>
             </a:r>
           </a:p>
         </p:txBody>
@@ -10774,7 +10774,7 @@
                 <a:latin typeface="Helvetica"/>
                 <a:ea typeface="Helvetica"/>
               </a:rPr>
-              <a:t>CLMS · 24CSI015 · Software Engineering with Agile Practices</a:t>
+              <a:t>KCT Library · 24CSI015 · Software Engineering with Agile Practices</a:t>
             </a:r>
           </a:p>
         </p:txBody>
@@ -11995,7 +11995,7 @@
                 <a:latin typeface="Helvetica"/>
                 <a:ea typeface="Helvetica"/>
               </a:rPr>
-              <a:t>CLMS · 24CSI015 · Software Engineering with Agile Practices</a:t>
+              <a:t>KCT Library · 24CSI015 · Software Engineering with Agile Practices</a:t>
             </a:r>
           </a:p>
         </p:txBody>
@@ -12966,7 +12966,7 @@
                 <a:latin typeface="Helvetica"/>
                 <a:ea typeface="Helvetica"/>
               </a:rPr>
-              <a:t>CLMS · 24CSI015 · Software Engineering with Agile Practices</a:t>
+              <a:t>KCT Library · 24CSI015 · Software Engineering with Agile Practices</a:t>
             </a:r>
           </a:p>
         </p:txBody>
@@ -13807,7 +13807,7 @@
                 <a:latin typeface="Helvetica"/>
                 <a:ea typeface="Helvetica"/>
               </a:rPr>
-              <a:t>CLMS · 24CSI015 · Software Engineering with Agile Practices</a:t>
+              <a:t>KCT Library · 24CSI015 · Software Engineering with Agile Practices</a:t>
             </a:r>
           </a:p>
         </p:txBody>
@@ -14778,7 +14778,7 @@
                 <a:latin typeface="Helvetica"/>
                 <a:ea typeface="Helvetica"/>
               </a:rPr>
-              <a:t>CLMS · 24CSI015 · Software Engineering with Agile Practices</a:t>
+              <a:t>KCT Library · 24CSI015 · Software Engineering with Agile Practices</a:t>
             </a:r>
           </a:p>
         </p:txBody>
@@ -15619,7 +15619,7 @@
                 <a:latin typeface="Helvetica"/>
                 <a:ea typeface="Helvetica"/>
               </a:rPr>
-              <a:t>CLMS ANSWERS</a:t>
+              <a:t>KCT LIBRARY ANSWERS</a:t>
             </a:r>
           </a:p>
         </p:txBody>
@@ -16314,7 +16314,7 @@
                 <a:latin typeface="Helvetica"/>
                 <a:ea typeface="Helvetica"/>
               </a:rPr>
-              <a:t>CLMS · 24CSI015 · Software Engineering with Agile Practices</a:t>
+              <a:t>KCT Library · 24CSI015 · Software Engineering with Agile Practices</a:t>
             </a:r>
           </a:p>
         </p:txBody>
@@ -17147,7 +17147,7 @@
                 <a:latin typeface="Helvetica"/>
                 <a:ea typeface="Helvetica"/>
               </a:rPr>
-              <a:t>CLMS · 24CSI015 · Software Engineering with Agile Practices</a:t>
+              <a:t>KCT Library · 24CSI015 · Software Engineering with Agile Practices</a:t>
             </a:r>
           </a:p>
         </p:txBody>
@@ -17464,7 +17464,7 @@
                           <a:latin typeface="Helvetica"/>
                           <a:ea typeface="Helvetica"/>
                         </a:rPr>
-                        <a:t>HOW CLMS ACTUALLY RAN</a:t>
+                        <a:t>HOW KCT Library ACTUALLY RAN</a:t>
                       </a:r>
                     </a:p>
                   </a:txBody>
@@ -17712,7 +17712,7 @@
                           <a:latin typeface="Menlo"/>
                           <a:ea typeface="Menlo"/>
                         </a:rPr>
-                        <a:t>Fit for CLMS</a:t>
+                        <a:t>Fit for KCT Library</a:t>
                       </a:r>
                     </a:p>
                   </a:txBody>
@@ -17980,7 +17980,7 @@
                 <a:latin typeface="Helvetica"/>
                 <a:ea typeface="Helvetica"/>
               </a:rPr>
-              <a:t>CLMS · 24CSI015 · Software Engineering with Agile Practices</a:t>
+              <a:t>KCT Library · 24CSI015 · Software Engineering with Agile Practices</a:t>
             </a:r>
           </a:p>
         </p:txBody>
@@ -19053,7 +19053,7 @@
                 <a:latin typeface="Helvetica"/>
                 <a:ea typeface="Helvetica"/>
               </a:rPr>
-              <a:t>CLMS · 24CSI015 · Software Engineering with Agile Practices</a:t>
+              <a:t>KCT Library · 24CSI015 · Software Engineering with Agile Practices</a:t>
             </a:r>
           </a:p>
         </p:txBody>
@@ -20874,7 +20874,7 @@
                 <a:latin typeface="Helvetica"/>
                 <a:ea typeface="Helvetica"/>
               </a:rPr>
-              <a:t>CLMS · 24CSI015 · Software Engineering with Agile Practices</a:t>
+              <a:t>KCT Library · 24CSI015 · Software Engineering with Agile Practices</a:t>
             </a:r>
           </a:p>
         </p:txBody>
@@ -21185,7 +21185,7 @@
                 <a:latin typeface="Helvetica"/>
                 <a:ea typeface="Helvetica"/>
               </a:rPr>
-              <a:t>CLMS · COLLEGE LIBRARY MANAGEMENT SYSTEM</a:t>
+              <a:t>KCT Library · COLLEGE LIBRARY MANAGEMENT SYSTEM</a:t>
             </a:r>
           </a:p>
         </p:txBody>
@@ -23000,7 +23000,7 @@
                 <a:latin typeface="Helvetica"/>
                 <a:ea typeface="Helvetica"/>
               </a:rPr>
-              <a:t>CLMS · 24CSI015 · Software Engineering with Agile Practices</a:t>
+              <a:t>KCT Library · 24CSI015 · Software Engineering with Agile Practices</a:t>
             </a:r>
           </a:p>
         </p:txBody>
@@ -23988,7 +23988,7 @@
                 <a:latin typeface="Helvetica"/>
                 <a:ea typeface="Helvetica"/>
               </a:rPr>
-              <a:t>CLMS · 24CSI015 · Software Engineering with Agile Practices</a:t>
+              <a:t>KCT Library · 24CSI015 · Software Engineering with Agile Practices</a:t>
             </a:r>
           </a:p>
         </p:txBody>

</xml_diff>